<commit_message>
docs: end every plan price in 499 and add the rounding rule
Growth 3,499, Scale 7,499 and Enterprise 15,499 a month; yearly is
11 x monthly plus 10, so it ends in 499 too. Solo and the Custom
estimate in the client deck are unchanged. PLAN.md gains the rounding
rule for the Custom formula and an acceptance check for the builder.
The deck's plans slide and its PDF carry the new prices.

Co-Authored-By: Claude Opus 5.5 <noreply@anthropic.com>
</commit_message>
<xml_diff>
--- a/Orelu-CA-Firms-Plan.pptx
+++ b/Orelu-CA-Firms-Plan.pptx
@@ -6646,7 +6646,7 @@
                           <a:ea typeface="Arial" pitchFamily="34" charset="-122"/>
                           <a:cs typeface="Arial" pitchFamily="34" charset="-120"/>
                         </a:rPr>
-                        <a:t>₹3,799</a:t>
+                        <a:t>₹3,499</a:t>
                       </a:r>
                     </a:p>
                   </a:txBody>
@@ -6687,7 +6687,7 @@
                           <a:ea typeface="Arial" pitchFamily="34" charset="-122"/>
                           <a:cs typeface="Arial" pitchFamily="34" charset="-120"/>
                         </a:rPr>
-                        <a:t>₹7,649</a:t>
+                        <a:t>₹7,499</a:t>
                       </a:r>
                     </a:p>
                   </a:txBody>
@@ -6728,7 +6728,7 @@
                           <a:ea typeface="Arial" pitchFamily="34" charset="-122"/>
                           <a:cs typeface="Arial" pitchFamily="34" charset="-120"/>
                         </a:rPr>
-                        <a:t>₹15,299</a:t>
+                        <a:t>₹15,499</a:t>
                       </a:r>
                     </a:p>
                   </a:txBody>
@@ -6894,7 +6894,7 @@
                           <a:ea typeface="Arial" pitchFamily="34" charset="-122"/>
                           <a:cs typeface="Arial" pitchFamily="34" charset="-120"/>
                         </a:rPr>
-                        <a:t>₹41,799</a:t>
+                        <a:t>₹38,499</a:t>
                       </a:r>
                     </a:p>
                   </a:txBody>
@@ -6935,7 +6935,7 @@
                           <a:ea typeface="Arial" pitchFamily="34" charset="-122"/>
                           <a:cs typeface="Arial" pitchFamily="34" charset="-120"/>
                         </a:rPr>
-                        <a:t>₹84,149</a:t>
+                        <a:t>₹82,499</a:t>
                       </a:r>
                     </a:p>
                   </a:txBody>
@@ -6976,7 +6976,7 @@
                           <a:ea typeface="Arial" pitchFamily="34" charset="-122"/>
                           <a:cs typeface="Arial" pitchFamily="34" charset="-120"/>
                         </a:rPr>
-                        <a:t>₹1,68,299</a:t>
+                        <a:t>₹1,70,499</a:t>
                       </a:r>
                     </a:p>
                   </a:txBody>

</xml_diff>